<commit_message>
paper: demo and Cockpit figures recaptured on the current product
- Demo figure (S1–S3) regenerated from a live run of the demo agent
  (Claude Haiku 4.5) against the current gateway and Cockpit; the S3 panel
  now crops the evidence-first approval card. Appendix C.1 adds the full
  agent pages for S1–S3, the held card, and the session in Activity.
- Appendix Cockpit figures all from the current build: DSL, alignment,
  scan, settings recaptured; Policy Packs and Settings added.
- shoot_demo.mjs matched a badge text the agent UI no longer uses
  ('success' vs ALLOWED), so S1 and S3 retried eight times; fixed. The
  demo gateway runs without the provenance pack, as sec:demo describes.

Co-Authored-By: Claude Fable 5.1 <noreply@anthropic.com>
</commit_message>
<xml_diff>
--- a/research/paper-arxiv/images/demo_walkthrough.pptx
+++ b/research/paper-arxiv/images/demo_walkthrough.pptx
@@ -4241,7 +4241,7 @@
       </p:sp>
       <p:pic>
         <p:nvPicPr>
-          <p:cNvPr id="33" name="Picture 32" descr="agent-s2.0.20-0.12-0.80-0.47.png"/>
+          <p:cNvPr id="33" name="Picture 32" descr="agent-S2.0.20-0.12-0.80-0.47.png"/>
           <p:cNvPicPr>
             <a:picLocks noChangeAspect="1"/>
           </p:cNvPicPr>
@@ -4556,7 +4556,7 @@
       </p:sp>
       <p:pic>
         <p:nvPicPr>
-          <p:cNvPr id="42" name="Picture 41" descr="approvals.0.19-0.20-0.97-0.44.png"/>
+          <p:cNvPr id="42" name="Picture 41" descr="approvals-s3.0.19-0.23-0.66-0.35.png"/>
           <p:cNvPicPr>
             <a:picLocks noChangeAspect="1"/>
           </p:cNvPicPr>
@@ -4571,51 +4571,16 @@
         <p:spPr>
           <a:xfrm>
             <a:off x="8775700" y="1689100"/>
-            <a:ext cx="3683000" cy="1219200"/>
+            <a:ext cx="3683000" cy="736600"/>
           </a:xfrm>
           <a:prstGeom prst="rect">
             <a:avLst/>
           </a:prstGeom>
         </p:spPr>
       </p:pic>
-      <p:sp>
-        <p:nvSpPr>
-          <p:cNvPr id="43" name="TextBox 42"/>
-          <p:cNvSpPr txBox="1"/>
-          <p:nvPr/>
-        </p:nvSpPr>
-        <p:spPr>
-          <a:xfrm>
-            <a:off x="8763000" y="2963545"/>
-            <a:ext cx="3724402" cy="301752"/>
-          </a:xfrm>
-          <a:prstGeom prst="rect">
-            <a:avLst/>
-          </a:prstGeom>
-          <a:noFill/>
-        </p:spPr>
-        <p:txBody>
-          <a:bodyPr wrap="none" lIns="0" rIns="0" tIns="0" bIns="0" anchor="t">
-            <a:spAutoFit/>
-          </a:bodyPr>
-          <a:lstStyle/>
-          <a:p>
-            <a:pPr algn="l"/>
-            <a:r>
-              <a:rPr sz="1100" b="0" i="1">
-                <a:solidFill>
-                  <a:srgbClr val="4D4D4D"/>
-                </a:solidFill>
-                <a:latin typeface="Geist"/>
-              </a:rPr>
-              <a:t>the held call — a second person presses one</a:t>
-            </a:r>
-          </a:p>
-        </p:txBody>
-      </p:sp>
       <p:pic>
         <p:nvPicPr>
-          <p:cNvPr id="44" name="Picture 43" descr="hand-stop--a96500.256.png"/>
+          <p:cNvPr id="43" name="Picture 42" descr="approvals-s3.0.78-0.52-0.95-0.58.png"/>
           <p:cNvPicPr>
             <a:picLocks noChangeAspect="1"/>
           </p:cNvPicPr>
@@ -4629,6 +4594,65 @@
         </p:blipFill>
         <p:spPr>
           <a:xfrm>
+            <a:off x="10553700" y="2489200"/>
+            <a:ext cx="1905000" cy="393700"/>
+          </a:xfrm>
+          <a:prstGeom prst="rect">
+            <a:avLst/>
+          </a:prstGeom>
+        </p:spPr>
+      </p:pic>
+      <p:sp>
+        <p:nvSpPr>
+          <p:cNvPr id="44" name="TextBox 43"/>
+          <p:cNvSpPr txBox="1"/>
+          <p:nvPr/>
+        </p:nvSpPr>
+        <p:spPr>
+          <a:xfrm>
+            <a:off x="8763000" y="2963545"/>
+            <a:ext cx="3724402" cy="301752"/>
+          </a:xfrm>
+          <a:prstGeom prst="rect">
+            <a:avLst/>
+          </a:prstGeom>
+          <a:noFill/>
+        </p:spPr>
+        <p:txBody>
+          <a:bodyPr wrap="none" lIns="0" rIns="0" tIns="0" bIns="0" anchor="t">
+            <a:spAutoFit/>
+          </a:bodyPr>
+          <a:lstStyle/>
+          <a:p>
+            <a:pPr algn="l"/>
+            <a:r>
+              <a:rPr sz="1100" b="0" i="1">
+                <a:solidFill>
+                  <a:srgbClr val="4D4D4D"/>
+                </a:solidFill>
+                <a:latin typeface="Geist"/>
+              </a:rPr>
+              <a:t>the held call — a second person presses one</a:t>
+            </a:r>
+          </a:p>
+        </p:txBody>
+      </p:sp>
+      <p:pic>
+        <p:nvPicPr>
+          <p:cNvPr id="45" name="Picture 44" descr="hand-stop--a96500.256.png"/>
+          <p:cNvPicPr>
+            <a:picLocks noChangeAspect="1"/>
+          </p:cNvPicPr>
+          <p:nvPr/>
+        </p:nvPicPr>
+        <p:blipFill>
+          <a:blip r:embed="rId8"/>
+          <a:stretch>
+            <a:fillRect/>
+          </a:stretch>
+        </p:blipFill>
+        <p:spPr>
+          <a:xfrm>
             <a:off x="8763000" y="3276600"/>
             <a:ext cx="190500" cy="190500"/>
           </a:xfrm>
@@ -4639,7 +4663,7 @@
       </p:pic>
       <p:sp>
         <p:nvSpPr>
-          <p:cNvPr id="45" name="TextBox 44"/>
+          <p:cNvPr id="46" name="TextBox 45"/>
           <p:cNvSpPr txBox="1"/>
           <p:nvPr/>
         </p:nvSpPr>
@@ -4674,7 +4698,7 @@
       </p:sp>
       <p:sp>
         <p:nvSpPr>
-          <p:cNvPr id="46" name="Rounded Rectangle 45"/>
+          <p:cNvPr id="47" name="Rounded Rectangle 46"/>
           <p:cNvSpPr/>
           <p:nvPr/>
         </p:nvSpPr>
@@ -4720,14 +4744,14 @@
       </p:sp>
       <p:pic>
         <p:nvPicPr>
-          <p:cNvPr id="47" name="Picture 46" descr="users--4d4d4d.256.png"/>
+          <p:cNvPr id="48" name="Picture 47" descr="users--4d4d4d.256.png"/>
           <p:cNvPicPr>
             <a:picLocks noChangeAspect="1"/>
           </p:cNvPicPr>
           <p:nvPr/>
         </p:nvPicPr>
         <p:blipFill>
-          <a:blip r:embed="rId8"/>
+          <a:blip r:embed="rId9"/>
           <a:stretch>
             <a:fillRect/>
           </a:stretch>
@@ -4744,7 +4768,7 @@
       </p:pic>
       <p:sp>
         <p:nvSpPr>
-          <p:cNvPr id="48" name="TextBox 47"/>
+          <p:cNvPr id="49" name="TextBox 48"/>
           <p:cNvSpPr txBox="1"/>
           <p:nvPr/>
         </p:nvSpPr>
@@ -4779,7 +4803,7 @@
       </p:sp>
       <p:sp>
         <p:nvSpPr>
-          <p:cNvPr id="49" name="TextBox 48"/>
+          <p:cNvPr id="50" name="TextBox 49"/>
           <p:cNvSpPr txBox="1"/>
           <p:nvPr/>
         </p:nvSpPr>
@@ -4814,7 +4838,7 @@
       </p:sp>
       <p:sp>
         <p:nvSpPr>
-          <p:cNvPr id="50" name="TextBox 49"/>
+          <p:cNvPr id="51" name="TextBox 50"/>
           <p:cNvSpPr txBox="1"/>
           <p:nvPr/>
         </p:nvSpPr>
@@ -4849,7 +4873,7 @@
       </p:sp>
       <p:sp>
         <p:nvSpPr>
-          <p:cNvPr id="51" name="TextBox 50"/>
+          <p:cNvPr id="52" name="TextBox 51"/>
           <p:cNvSpPr txBox="1"/>
           <p:nvPr/>
         </p:nvSpPr>
@@ -4884,7 +4908,7 @@
       </p:sp>
       <p:sp>
         <p:nvSpPr>
-          <p:cNvPr id="52" name="TextBox 51"/>
+          <p:cNvPr id="53" name="TextBox 52"/>
           <p:cNvSpPr txBox="1"/>
           <p:nvPr/>
         </p:nvSpPr>

</xml_diff>